<commit_message>
Refresh capstone evidence and version both app walkthroughs
Lesson: Regenerate submission files from shared facts and verify the rendered result.
</commit_message>
<xml_diff>
--- a/submission/artifacts/DragonWings_90_Second_Pitch.pptx
+++ b/submission/artifacts/DragonWings_90_Second_Pitch.pptx
@@ -2,15 +2,15 @@
 <file path=ppt/presentation.xml><?xml version="1.0" encoding="utf-8"?>
 <p:presentation xmlns:p="http://schemas.openxmlformats.org/presentationml/2006/main">
   <p:sldMasterIdLst>
-    <p:sldMasterId xmlns:r="http://schemas.openxmlformats.org/officeDocument/2006/relationships" id="2147483648" r:id="R70f279f924f947a0"/>
+    <p:sldMasterId xmlns:r="http://schemas.openxmlformats.org/officeDocument/2006/relationships" id="2147483648" r:id="Radb42a11f3404266"/>
   </p:sldMasterIdLst>
   <p:notesMasterIdLst>
-    <p:notesMasterId xmlns:r="http://schemas.openxmlformats.org/officeDocument/2006/relationships" r:id="Rc72cb8ba011543d2"/>
+    <p:notesMasterId xmlns:r="http://schemas.openxmlformats.org/officeDocument/2006/relationships" r:id="Rb5a700b15a264ab8"/>
   </p:notesMasterIdLst>
   <p:sldIdLst>
-    <p:sldId xmlns:r="http://schemas.openxmlformats.org/officeDocument/2006/relationships" id="256" r:id="R403b5fb15ff54bb6"/>
-    <p:sldId xmlns:r="http://schemas.openxmlformats.org/officeDocument/2006/relationships" id="257" r:id="Rf939acd0fad64441"/>
-    <p:sldId xmlns:r="http://schemas.openxmlformats.org/officeDocument/2006/relationships" id="258" r:id="R74871f916fcd484b"/>
+    <p:sldId xmlns:r="http://schemas.openxmlformats.org/officeDocument/2006/relationships" id="256" r:id="R2c9dcb3ae9444aa9"/>
+    <p:sldId xmlns:r="http://schemas.openxmlformats.org/officeDocument/2006/relationships" id="257" r:id="R6d41b6778dc04310"/>
+    <p:sldId xmlns:r="http://schemas.openxmlformats.org/officeDocument/2006/relationships" id="258" r:id="R420f548c8a494f76"/>
   </p:sldIdLst>
   <p:sldSz cx="12192000" cy="6858000"/>
   <p:notesSz cx="6858000" cy="9144000"/>
@@ -469,7 +469,7 @@
           </a:p>
           <a:p xmlns:a="http://schemas.openxmlformats.org/drawingml/2006/main">
             <a:r>
-              <a:t>R1: https://github.com/roboyak/PAP-Agent/blob/74cc759/README.md</a:t>
+              <a:t>R1: https://github.com/roboyak/PAP-Agent/blob/aa61ba7f1e5fe87c90b7182ea8ba82e1cdc94ca5/README.md</a:t>
             </a:r>
           </a:p>
           <a:p xmlns:a="http://schemas.openxmlformats.org/drawingml/2006/main">
@@ -574,12 +574,12 @@
           </a:p>
           <a:p xmlns:a="http://schemas.openxmlformats.org/drawingml/2006/main">
             <a:r>
-              <a:t>R1: https://github.com/roboyak/PAP-Agent/blob/74cc759/README.md</a:t>
-            </a:r>
-          </a:p>
-          <a:p xmlns:a="http://schemas.openxmlformats.org/drawingml/2006/main">
-            <a:r>
-              <a:t>R2: https://github.com/roboyak/PAP-Agent/blob/74cc759/docs/architecture/FINAL_MVP.md</a:t>
+              <a:t>R1: https://github.com/roboyak/PAP-Agent/blob/aa61ba7f1e5fe87c90b7182ea8ba82e1cdc94ca5/README.md</a:t>
+            </a:r>
+          </a:p>
+          <a:p xmlns:a="http://schemas.openxmlformats.org/drawingml/2006/main">
+            <a:r>
+              <a:t>R2: https://github.com/roboyak/PAP-Agent/blob/aa61ba7f1e5fe87c90b7182ea8ba82e1cdc94ca5/docs/architecture/FINAL_MVP.md</a:t>
             </a:r>
           </a:p>
           <a:p xmlns:a="http://schemas.openxmlformats.org/drawingml/2006/main">
@@ -669,7 +669,7 @@
           </a:p>
           <a:p xmlns:a="http://schemas.openxmlformats.org/drawingml/2006/main">
             <a:r>
-              <a:t>The local gate passed forty unit and integration tests plus ten browser checks. One live comparison kept the same power calculation while the third agent added latency without a demonstrated quality benefit. The forecast still uses synthetic weather factors and needs broader evaluation. My takeaway is that useful agent autonomy needs clear authority and visible evidence. DragonWings PAP makes that boundary concrete in a working local system.</a:t>
+              <a:t>The local gate passed forty-four unit and integration tests plus thirteen browser checks. One live comparison kept the same power calculation while the third agent added latency without a demonstrated quality benefit. The forecast still uses synthetic weather factors and needs broader evaluation. My takeaway is that useful agent autonomy needs clear authority and visible evidence. DragonWings PAP makes that boundary concrete in a working local system.</a:t>
             </a:r>
           </a:p>
           <a:p xmlns:a="http://schemas.openxmlformats.org/drawingml/2006/main">
@@ -684,12 +684,12 @@
           </a:p>
           <a:p xmlns:a="http://schemas.openxmlformats.org/drawingml/2006/main">
             <a:r>
-              <a:t>R5: https://github.com/roboyak/PAP-Agent/blob/74cc759/docs/pr/PR-11.md</a:t>
-            </a:r>
-          </a:p>
-          <a:p xmlns:a="http://schemas.openxmlformats.org/drawingml/2006/main">
-            <a:r>
-              <a:t>R6: https://github.com/roboyak/PAP-Agent/blob/74cc759/docs/pr/PR-12.md</a:t>
+              <a:t>R5: https://github.com/roboyak/PAP-Agent/blob/aa61ba7f1e5fe87c90b7182ea8ba82e1cdc94ca5/docs/pr/PR-11.md</a:t>
+            </a:r>
+          </a:p>
+          <a:p xmlns:a="http://schemas.openxmlformats.org/drawingml/2006/main">
+            <a:r>
+              <a:t>R8: https://github.com/roboyak/PAP-Agent/blob/aa61ba7f1e5fe87c90b7182ea8ba82e1cdc94ca5/docs/pr/PR-15.md</a:t>
             </a:r>
           </a:p>
           <a:p xmlns:a="http://schemas.openxmlformats.org/drawingml/2006/main">
@@ -767,7 +767,7 @@
   </p:cSld>
   <p:clrMap bg1="lt1" tx1="dk1" bg2="lt2" tx2="dk2" accent1="accent1" accent2="accent2" accent3="accent3" accent4="accent4" accent5="accent5" accent6="accent6" hlink="hlink" folHlink="folHlink"/>
   <p:sldLayoutIdLst>
-    <p:sldLayoutId xmlns:r="http://schemas.openxmlformats.org/officeDocument/2006/relationships" id="2147483649" r:id="Rf8ed76fb5915416f"/>
+    <p:sldLayoutId xmlns:r="http://schemas.openxmlformats.org/officeDocument/2006/relationships" id="2147483649" r:id="R508f72d67e2d4c89"/>
   </p:sldLayoutIdLst>
   <p:txStyles>
     <p:titleStyle>
@@ -1322,7 +1322,7 @@
           <p:nvPr/>
         </p:nvPicPr>
         <p:blipFill>
-          <a:blip xmlns:r="http://schemas.openxmlformats.org/officeDocument/2006/relationships" xmlns:a="http://schemas.openxmlformats.org/drawingml/2006/main" r:embed="Ra613d09bbc6b4542"/>
+          <a:blip xmlns:r="http://schemas.openxmlformats.org/officeDocument/2006/relationships" xmlns:a="http://schemas.openxmlformats.org/drawingml/2006/main" r:embed="R4a7d89aa0a5e43a8"/>
           <a:srcRect xmlns:a="http://schemas.openxmlformats.org/drawingml/2006/main" l="0" t="27" r="0" b="27"/>
           <a:stretch xmlns:a="http://schemas.openxmlformats.org/drawingml/2006/main">
             <a:fillRect l="0" t="0" r="0" b="0"/>
@@ -1343,7 +1343,7 @@
           <p:cNvPr id="2" name="">
             <a:extLst xmlns:a="http://schemas.openxmlformats.org/drawingml/2006/main">
               <a:ext uri="{FF2B5EF4-FFF2-40B4-BE49-F238E27FC236}">
-                <a16:creationId xmlns:a16="http://schemas.microsoft.com/office/drawing/2014/main" id="{1F5DFF71-4FBF-48BE-8831-A79B26EB05EB}"/>
+                <a16:creationId xmlns:a16="http://schemas.microsoft.com/office/drawing/2014/main" id="{8313969A-A6C4-4150-8271-020BC6FC9010}"/>
               </a:ext>
             </a:extLst>
           </p:cNvPr>
@@ -1400,7 +1400,7 @@
           <p:cNvPr id="3" name="">
             <a:extLst xmlns:a="http://schemas.openxmlformats.org/drawingml/2006/main">
               <a:ext uri="{FF2B5EF4-FFF2-40B4-BE49-F238E27FC236}">
-                <a16:creationId xmlns:a16="http://schemas.microsoft.com/office/drawing/2014/main" id="{D794C5B6-B736-4504-9C25-8E115F446219}"/>
+                <a16:creationId xmlns:a16="http://schemas.microsoft.com/office/drawing/2014/main" id="{932CAD91-F822-4EB9-BC9C-A3F4E3B6A8F6}"/>
               </a:ext>
             </a:extLst>
           </p:cNvPr>
@@ -1457,7 +1457,7 @@
           <p:cNvPr id="4" name="">
             <a:extLst xmlns:a="http://schemas.openxmlformats.org/drawingml/2006/main">
               <a:ext uri="{FF2B5EF4-FFF2-40B4-BE49-F238E27FC236}">
-                <a16:creationId xmlns:a16="http://schemas.microsoft.com/office/drawing/2014/main" id="{274C8F75-5319-415A-8370-8FF1E77B4DBD}"/>
+                <a16:creationId xmlns:a16="http://schemas.microsoft.com/office/drawing/2014/main" id="{BFDD9D01-D525-4AFA-98D7-60A2C8BC4AA6}"/>
               </a:ext>
             </a:extLst>
           </p:cNvPr>
@@ -1560,7 +1560,7 @@
           <p:cNvPr id="5" name="">
             <a:extLst xmlns:a="http://schemas.openxmlformats.org/drawingml/2006/main">
               <a:ext uri="{FF2B5EF4-FFF2-40B4-BE49-F238E27FC236}">
-                <a16:creationId xmlns:a16="http://schemas.microsoft.com/office/drawing/2014/main" id="{B1E7442A-D526-488C-992B-E5C8EB027099}"/>
+                <a16:creationId xmlns:a16="http://schemas.microsoft.com/office/drawing/2014/main" id="{B1FAA834-69FD-44A7-828B-0FAEF01A018C}"/>
               </a:ext>
             </a:extLst>
           </p:cNvPr>
@@ -1617,7 +1617,7 @@
           <p:cNvPr id="6" name="">
             <a:extLst xmlns:a="http://schemas.openxmlformats.org/drawingml/2006/main">
               <a:ext uri="{FF2B5EF4-FFF2-40B4-BE49-F238E27FC236}">
-                <a16:creationId xmlns:a16="http://schemas.microsoft.com/office/drawing/2014/main" id="{DFD24948-EE81-4DB1-82F0-BD05D5111FC2}"/>
+                <a16:creationId xmlns:a16="http://schemas.microsoft.com/office/drawing/2014/main" id="{3CE79009-9A13-417A-A62F-053261CBDCE9}"/>
               </a:ext>
             </a:extLst>
           </p:cNvPr>
@@ -1672,7 +1672,7 @@
     </p:spTree>
     <p:extLst>
       <p:ext uri="{BB962C8B-B14F-4D97-AF65-F5344CB8AC3E}">
-        <p14:creationId xmlns:p14="http://schemas.microsoft.com/office/powerpoint/2010/main" val="623763796"/>
+        <p14:creationId xmlns:p14="http://schemas.microsoft.com/office/powerpoint/2010/main" val="2046820633"/>
       </p:ext>
     </p:extLst>
   </p:cSld>
@@ -1703,7 +1703,7 @@
           <p:cNvPr id="13" name="">
             <a:extLst xmlns:a="http://schemas.openxmlformats.org/drawingml/2006/main">
               <a:ext uri="{FF2B5EF4-FFF2-40B4-BE49-F238E27FC236}">
-                <a16:creationId xmlns:a16="http://schemas.microsoft.com/office/drawing/2014/main" id="{8FAC460E-5CC8-49B4-B02F-6F3812A27DB9}"/>
+                <a16:creationId xmlns:a16="http://schemas.microsoft.com/office/drawing/2014/main" id="{1BC3456E-9600-43DF-9747-22C644931DAE}"/>
               </a:ext>
             </a:extLst>
           </p:cNvPr>
@@ -1760,7 +1760,7 @@
           <p:cNvPr id="2" name="">
             <a:extLst xmlns:a="http://schemas.openxmlformats.org/drawingml/2006/main">
               <a:ext uri="{FF2B5EF4-FFF2-40B4-BE49-F238E27FC236}">
-                <a16:creationId xmlns:a16="http://schemas.microsoft.com/office/drawing/2014/main" id="{39AA55B1-FCF0-4B36-BB43-B9368FB89C1C}"/>
+                <a16:creationId xmlns:a16="http://schemas.microsoft.com/office/drawing/2014/main" id="{E3ADF1DB-E81C-479C-BC53-0A3941BC51A2}"/>
               </a:ext>
             </a:extLst>
           </p:cNvPr>
@@ -1817,7 +1817,7 @@
           <p:cNvPr id="3" name="">
             <a:extLst xmlns:a="http://schemas.openxmlformats.org/drawingml/2006/main">
               <a:ext uri="{FF2B5EF4-FFF2-40B4-BE49-F238E27FC236}">
-                <a16:creationId xmlns:a16="http://schemas.microsoft.com/office/drawing/2014/main" id="{B702168F-DD7E-4FEB-9063-17030DD8E71E}"/>
+                <a16:creationId xmlns:a16="http://schemas.microsoft.com/office/drawing/2014/main" id="{925123DC-D7A9-4E8A-B3B6-13FCDB3CC3A0}"/>
               </a:ext>
             </a:extLst>
           </p:cNvPr>
@@ -1874,7 +1874,7 @@
           <p:cNvPr id="4" name="">
             <a:extLst xmlns:a="http://schemas.openxmlformats.org/drawingml/2006/main">
               <a:ext uri="{FF2B5EF4-FFF2-40B4-BE49-F238E27FC236}">
-                <a16:creationId xmlns:a16="http://schemas.microsoft.com/office/drawing/2014/main" id="{043EADF5-EBBC-4A14-B6CA-B4447BFBD47C}"/>
+                <a16:creationId xmlns:a16="http://schemas.microsoft.com/office/drawing/2014/main" id="{BD5CA67F-E83A-4EE6-A180-1CE4A5ACEBF6}"/>
               </a:ext>
             </a:extLst>
           </p:cNvPr>
@@ -1958,7 +1958,7 @@
           <p:cNvPr id="5" name="">
             <a:extLst xmlns:a="http://schemas.openxmlformats.org/drawingml/2006/main">
               <a:ext uri="{FF2B5EF4-FFF2-40B4-BE49-F238E27FC236}">
-                <a16:creationId xmlns:a16="http://schemas.microsoft.com/office/drawing/2014/main" id="{D2F9911D-E602-4614-9FFA-24398FE40D73}"/>
+                <a16:creationId xmlns:a16="http://schemas.microsoft.com/office/drawing/2014/main" id="{2484C547-B563-49FA-A530-5A5ADA4121AF}"/>
               </a:ext>
             </a:extLst>
           </p:cNvPr>
@@ -2042,7 +2042,7 @@
           <p:cNvPr id="6" name="">
             <a:extLst xmlns:a="http://schemas.openxmlformats.org/drawingml/2006/main">
               <a:ext uri="{FF2B5EF4-FFF2-40B4-BE49-F238E27FC236}">
-                <a16:creationId xmlns:a16="http://schemas.microsoft.com/office/drawing/2014/main" id="{DE533EAA-08D1-4EC4-8F70-6B4F3EFD7014}"/>
+                <a16:creationId xmlns:a16="http://schemas.microsoft.com/office/drawing/2014/main" id="{FF4D6FA5-3F87-423A-BA21-0F8626FF4ECD}"/>
               </a:ext>
             </a:extLst>
           </p:cNvPr>
@@ -2126,7 +2126,7 @@
           <p:cNvPr id="7" name="">
             <a:extLst xmlns:a="http://schemas.openxmlformats.org/drawingml/2006/main">
               <a:ext uri="{FF2B5EF4-FFF2-40B4-BE49-F238E27FC236}">
-                <a16:creationId xmlns:a16="http://schemas.microsoft.com/office/drawing/2014/main" id="{BDEC91BF-C754-46D4-A789-1783FC4570A7}"/>
+                <a16:creationId xmlns:a16="http://schemas.microsoft.com/office/drawing/2014/main" id="{4A4DBCE8-B68F-4CD3-A288-45C1F428B479}"/>
               </a:ext>
             </a:extLst>
           </p:cNvPr>
@@ -2288,7 +2288,7 @@
           <p:cNvPr id="11" name="">
             <a:extLst xmlns:a="http://schemas.openxmlformats.org/drawingml/2006/main">
               <a:ext uri="{FF2B5EF4-FFF2-40B4-BE49-F238E27FC236}">
-                <a16:creationId xmlns:a16="http://schemas.microsoft.com/office/drawing/2014/main" id="{B43AF6EF-8D3E-44AE-98BC-F3C838670F84}"/>
+                <a16:creationId xmlns:a16="http://schemas.microsoft.com/office/drawing/2014/main" id="{11032270-20F9-4A08-8A08-1F3BF89C84DA}"/>
               </a:ext>
             </a:extLst>
           </p:cNvPr>
@@ -2345,7 +2345,7 @@
           <p:cNvPr id="12" name="">
             <a:extLst xmlns:a="http://schemas.openxmlformats.org/drawingml/2006/main">
               <a:ext uri="{FF2B5EF4-FFF2-40B4-BE49-F238E27FC236}">
-                <a16:creationId xmlns:a16="http://schemas.microsoft.com/office/drawing/2014/main" id="{C51D02B7-D165-400B-9EEF-2E3AC6C88794}"/>
+                <a16:creationId xmlns:a16="http://schemas.microsoft.com/office/drawing/2014/main" id="{3BB1C224-125F-4AB3-9086-6793EC6CAD9F}"/>
               </a:ext>
             </a:extLst>
           </p:cNvPr>
@@ -2400,7 +2400,7 @@
     </p:spTree>
     <p:extLst>
       <p:ext uri="{BB962C8B-B14F-4D97-AF65-F5344CB8AC3E}">
-        <p14:creationId xmlns:p14="http://schemas.microsoft.com/office/powerpoint/2010/main" val="389264615"/>
+        <p14:creationId xmlns:p14="http://schemas.microsoft.com/office/powerpoint/2010/main" val="1639094115"/>
       </p:ext>
     </p:extLst>
   </p:cSld>
@@ -2431,7 +2431,7 @@
           <p:cNvPr id="8" name="">
             <a:extLst xmlns:a="http://schemas.openxmlformats.org/drawingml/2006/main">
               <a:ext uri="{FF2B5EF4-FFF2-40B4-BE49-F238E27FC236}">
-                <a16:creationId xmlns:a16="http://schemas.microsoft.com/office/drawing/2014/main" id="{3BC7E928-D3AB-409C-ABDA-53693B9E7DED}"/>
+                <a16:creationId xmlns:a16="http://schemas.microsoft.com/office/drawing/2014/main" id="{310F5B05-9A93-4233-8F6A-AC64465E656E}"/>
               </a:ext>
             </a:extLst>
           </p:cNvPr>
@@ -2488,7 +2488,7 @@
           <p:cNvPr id="2" name="">
             <a:extLst xmlns:a="http://schemas.openxmlformats.org/drawingml/2006/main">
               <a:ext uri="{FF2B5EF4-FFF2-40B4-BE49-F238E27FC236}">
-                <a16:creationId xmlns:a16="http://schemas.microsoft.com/office/drawing/2014/main" id="{E16DC21D-B606-45EF-9F92-D315093E87D4}"/>
+                <a16:creationId xmlns:a16="http://schemas.microsoft.com/office/drawing/2014/main" id="{A84CDB18-DFB0-4183-B9F6-3B759D719BA8}"/>
               </a:ext>
             </a:extLst>
           </p:cNvPr>
@@ -2568,7 +2568,7 @@
           <p:cNvPr id="3" name="">
             <a:extLst xmlns:a="http://schemas.openxmlformats.org/drawingml/2006/main">
               <a:ext uri="{FF2B5EF4-FFF2-40B4-BE49-F238E27FC236}">
-                <a16:creationId xmlns:a16="http://schemas.microsoft.com/office/drawing/2014/main" id="{7DA7D27F-1820-4949-AA4C-0BCBA9F6E99A}"/>
+                <a16:creationId xmlns:a16="http://schemas.microsoft.com/office/drawing/2014/main" id="{4073BD37-F263-40E0-8B76-49E4C20167E0}"/>
               </a:ext>
             </a:extLst>
           </p:cNvPr>
@@ -2625,7 +2625,7 @@
           <p:cNvPr id="4" name="">
             <a:extLst xmlns:a="http://schemas.openxmlformats.org/drawingml/2006/main">
               <a:ext uri="{FF2B5EF4-FFF2-40B4-BE49-F238E27FC236}">
-                <a16:creationId xmlns:a16="http://schemas.microsoft.com/office/drawing/2014/main" id="{74862F9D-55B3-41FF-A797-FDCC14C2BE14}"/>
+                <a16:creationId xmlns:a16="http://schemas.microsoft.com/office/drawing/2014/main" id="{DD989AC5-6AA3-4E10-ADCB-12790B1DD2A3}"/>
               </a:ext>
             </a:extLst>
           </p:cNvPr>
@@ -2672,7 +2672,7 @@
                 <a:ea typeface="Arial"/>
                 <a:cs typeface="Arial"/>
               </a:rPr>
-              <a:t>40 unit and integration tests</a:t>
+              <a:t>44 unit and integration tests</a:t>
             </a:r>
           </a:p>
           <a:p xmlns:a="http://schemas.openxmlformats.org/drawingml/2006/main">
@@ -2695,7 +2695,7 @@
                 <a:ea typeface="Arial"/>
                 <a:cs typeface="Arial"/>
               </a:rPr>
-              <a:t>10 Chromium browser checks</a:t>
+              <a:t>13 Chromium browser checks</a:t>
             </a:r>
           </a:p>
         </p:txBody>
@@ -2705,7 +2705,7 @@
           <p:cNvPr id="5" name="">
             <a:extLst xmlns:a="http://schemas.openxmlformats.org/drawingml/2006/main">
               <a:ext uri="{FF2B5EF4-FFF2-40B4-BE49-F238E27FC236}">
-                <a16:creationId xmlns:a16="http://schemas.microsoft.com/office/drawing/2014/main" id="{4E8E6D7A-728B-469C-8A4D-85C16512D584}"/>
+                <a16:creationId xmlns:a16="http://schemas.microsoft.com/office/drawing/2014/main" id="{96124F51-7ED9-429D-9B25-F061714F7A19}"/>
               </a:ext>
             </a:extLst>
           </p:cNvPr>
@@ -2762,7 +2762,7 @@
           <p:cNvPr id="6" name="">
             <a:extLst xmlns:a="http://schemas.openxmlformats.org/drawingml/2006/main">
               <a:ext uri="{FF2B5EF4-FFF2-40B4-BE49-F238E27FC236}">
-                <a16:creationId xmlns:a16="http://schemas.microsoft.com/office/drawing/2014/main" id="{B99E63A5-B97C-410C-847A-BB049269749E}"/>
+                <a16:creationId xmlns:a16="http://schemas.microsoft.com/office/drawing/2014/main" id="{31A04766-5723-4605-8A01-1B1D959C781E}"/>
               </a:ext>
             </a:extLst>
           </p:cNvPr>
@@ -2819,7 +2819,7 @@
           <p:cNvPr id="7" name="">
             <a:extLst xmlns:a="http://schemas.openxmlformats.org/drawingml/2006/main">
               <a:ext uri="{FF2B5EF4-FFF2-40B4-BE49-F238E27FC236}">
-                <a16:creationId xmlns:a16="http://schemas.microsoft.com/office/drawing/2014/main" id="{ADD764B8-C582-4F14-A9A3-8B722F30F8CA}"/>
+                <a16:creationId xmlns:a16="http://schemas.microsoft.com/office/drawing/2014/main" id="{B6C6BF17-BC37-4600-98A2-234D817FCBA1}"/>
               </a:ext>
             </a:extLst>
           </p:cNvPr>
@@ -2874,7 +2874,7 @@
     </p:spTree>
     <p:extLst>
       <p:ext uri="{BB962C8B-B14F-4D97-AF65-F5344CB8AC3E}">
-        <p14:creationId xmlns:p14="http://schemas.microsoft.com/office/powerpoint/2010/main" val="322683714"/>
+        <p14:creationId xmlns:p14="http://schemas.microsoft.com/office/powerpoint/2010/main" val="581716849"/>
       </p:ext>
     </p:extLst>
   </p:cSld>

</xml_diff>

<commit_message>
Refresh capstone evidence and version both app walkthroughs (#16)
Lesson: Regenerate submission files from shared facts and verify the rendered result.
</commit_message>
<xml_diff>
--- a/submission/artifacts/DragonWings_90_Second_Pitch.pptx
+++ b/submission/artifacts/DragonWings_90_Second_Pitch.pptx
@@ -2,15 +2,15 @@
 <file path=ppt/presentation.xml><?xml version="1.0" encoding="utf-8"?>
 <p:presentation xmlns:p="http://schemas.openxmlformats.org/presentationml/2006/main">
   <p:sldMasterIdLst>
-    <p:sldMasterId xmlns:r="http://schemas.openxmlformats.org/officeDocument/2006/relationships" id="2147483648" r:id="R70f279f924f947a0"/>
+    <p:sldMasterId xmlns:r="http://schemas.openxmlformats.org/officeDocument/2006/relationships" id="2147483648" r:id="Radb42a11f3404266"/>
   </p:sldMasterIdLst>
   <p:notesMasterIdLst>
-    <p:notesMasterId xmlns:r="http://schemas.openxmlformats.org/officeDocument/2006/relationships" r:id="Rc72cb8ba011543d2"/>
+    <p:notesMasterId xmlns:r="http://schemas.openxmlformats.org/officeDocument/2006/relationships" r:id="Rb5a700b15a264ab8"/>
   </p:notesMasterIdLst>
   <p:sldIdLst>
-    <p:sldId xmlns:r="http://schemas.openxmlformats.org/officeDocument/2006/relationships" id="256" r:id="R403b5fb15ff54bb6"/>
-    <p:sldId xmlns:r="http://schemas.openxmlformats.org/officeDocument/2006/relationships" id="257" r:id="Rf939acd0fad64441"/>
-    <p:sldId xmlns:r="http://schemas.openxmlformats.org/officeDocument/2006/relationships" id="258" r:id="R74871f916fcd484b"/>
+    <p:sldId xmlns:r="http://schemas.openxmlformats.org/officeDocument/2006/relationships" id="256" r:id="R2c9dcb3ae9444aa9"/>
+    <p:sldId xmlns:r="http://schemas.openxmlformats.org/officeDocument/2006/relationships" id="257" r:id="R6d41b6778dc04310"/>
+    <p:sldId xmlns:r="http://schemas.openxmlformats.org/officeDocument/2006/relationships" id="258" r:id="R420f548c8a494f76"/>
   </p:sldIdLst>
   <p:sldSz cx="12192000" cy="6858000"/>
   <p:notesSz cx="6858000" cy="9144000"/>
@@ -469,7 +469,7 @@
           </a:p>
           <a:p xmlns:a="http://schemas.openxmlformats.org/drawingml/2006/main">
             <a:r>
-              <a:t>R1: https://github.com/roboyak/PAP-Agent/blob/74cc759/README.md</a:t>
+              <a:t>R1: https://github.com/roboyak/PAP-Agent/blob/aa61ba7f1e5fe87c90b7182ea8ba82e1cdc94ca5/README.md</a:t>
             </a:r>
           </a:p>
           <a:p xmlns:a="http://schemas.openxmlformats.org/drawingml/2006/main">
@@ -574,12 +574,12 @@
           </a:p>
           <a:p xmlns:a="http://schemas.openxmlformats.org/drawingml/2006/main">
             <a:r>
-              <a:t>R1: https://github.com/roboyak/PAP-Agent/blob/74cc759/README.md</a:t>
-            </a:r>
-          </a:p>
-          <a:p xmlns:a="http://schemas.openxmlformats.org/drawingml/2006/main">
-            <a:r>
-              <a:t>R2: https://github.com/roboyak/PAP-Agent/blob/74cc759/docs/architecture/FINAL_MVP.md</a:t>
+              <a:t>R1: https://github.com/roboyak/PAP-Agent/blob/aa61ba7f1e5fe87c90b7182ea8ba82e1cdc94ca5/README.md</a:t>
+            </a:r>
+          </a:p>
+          <a:p xmlns:a="http://schemas.openxmlformats.org/drawingml/2006/main">
+            <a:r>
+              <a:t>R2: https://github.com/roboyak/PAP-Agent/blob/aa61ba7f1e5fe87c90b7182ea8ba82e1cdc94ca5/docs/architecture/FINAL_MVP.md</a:t>
             </a:r>
           </a:p>
           <a:p xmlns:a="http://schemas.openxmlformats.org/drawingml/2006/main">
@@ -669,7 +669,7 @@
           </a:p>
           <a:p xmlns:a="http://schemas.openxmlformats.org/drawingml/2006/main">
             <a:r>
-              <a:t>The local gate passed forty unit and integration tests plus ten browser checks. One live comparison kept the same power calculation while the third agent added latency without a demonstrated quality benefit. The forecast still uses synthetic weather factors and needs broader evaluation. My takeaway is that useful agent autonomy needs clear authority and visible evidence. DragonWings PAP makes that boundary concrete in a working local system.</a:t>
+              <a:t>The local gate passed forty-four unit and integration tests plus thirteen browser checks. One live comparison kept the same power calculation while the third agent added latency without a demonstrated quality benefit. The forecast still uses synthetic weather factors and needs broader evaluation. My takeaway is that useful agent autonomy needs clear authority and visible evidence. DragonWings PAP makes that boundary concrete in a working local system.</a:t>
             </a:r>
           </a:p>
           <a:p xmlns:a="http://schemas.openxmlformats.org/drawingml/2006/main">
@@ -684,12 +684,12 @@
           </a:p>
           <a:p xmlns:a="http://schemas.openxmlformats.org/drawingml/2006/main">
             <a:r>
-              <a:t>R5: https://github.com/roboyak/PAP-Agent/blob/74cc759/docs/pr/PR-11.md</a:t>
-            </a:r>
-          </a:p>
-          <a:p xmlns:a="http://schemas.openxmlformats.org/drawingml/2006/main">
-            <a:r>
-              <a:t>R6: https://github.com/roboyak/PAP-Agent/blob/74cc759/docs/pr/PR-12.md</a:t>
+              <a:t>R5: https://github.com/roboyak/PAP-Agent/blob/aa61ba7f1e5fe87c90b7182ea8ba82e1cdc94ca5/docs/pr/PR-11.md</a:t>
+            </a:r>
+          </a:p>
+          <a:p xmlns:a="http://schemas.openxmlformats.org/drawingml/2006/main">
+            <a:r>
+              <a:t>R8: https://github.com/roboyak/PAP-Agent/blob/aa61ba7f1e5fe87c90b7182ea8ba82e1cdc94ca5/docs/pr/PR-15.md</a:t>
             </a:r>
           </a:p>
           <a:p xmlns:a="http://schemas.openxmlformats.org/drawingml/2006/main">
@@ -767,7 +767,7 @@
   </p:cSld>
   <p:clrMap bg1="lt1" tx1="dk1" bg2="lt2" tx2="dk2" accent1="accent1" accent2="accent2" accent3="accent3" accent4="accent4" accent5="accent5" accent6="accent6" hlink="hlink" folHlink="folHlink"/>
   <p:sldLayoutIdLst>
-    <p:sldLayoutId xmlns:r="http://schemas.openxmlformats.org/officeDocument/2006/relationships" id="2147483649" r:id="Rf8ed76fb5915416f"/>
+    <p:sldLayoutId xmlns:r="http://schemas.openxmlformats.org/officeDocument/2006/relationships" id="2147483649" r:id="R508f72d67e2d4c89"/>
   </p:sldLayoutIdLst>
   <p:txStyles>
     <p:titleStyle>
@@ -1322,7 +1322,7 @@
           <p:nvPr/>
         </p:nvPicPr>
         <p:blipFill>
-          <a:blip xmlns:r="http://schemas.openxmlformats.org/officeDocument/2006/relationships" xmlns:a="http://schemas.openxmlformats.org/drawingml/2006/main" r:embed="Ra613d09bbc6b4542"/>
+          <a:blip xmlns:r="http://schemas.openxmlformats.org/officeDocument/2006/relationships" xmlns:a="http://schemas.openxmlformats.org/drawingml/2006/main" r:embed="R4a7d89aa0a5e43a8"/>
           <a:srcRect xmlns:a="http://schemas.openxmlformats.org/drawingml/2006/main" l="0" t="27" r="0" b="27"/>
           <a:stretch xmlns:a="http://schemas.openxmlformats.org/drawingml/2006/main">
             <a:fillRect l="0" t="0" r="0" b="0"/>
@@ -1343,7 +1343,7 @@
           <p:cNvPr id="2" name="">
             <a:extLst xmlns:a="http://schemas.openxmlformats.org/drawingml/2006/main">
               <a:ext uri="{FF2B5EF4-FFF2-40B4-BE49-F238E27FC236}">
-                <a16:creationId xmlns:a16="http://schemas.microsoft.com/office/drawing/2014/main" id="{1F5DFF71-4FBF-48BE-8831-A79B26EB05EB}"/>
+                <a16:creationId xmlns:a16="http://schemas.microsoft.com/office/drawing/2014/main" id="{8313969A-A6C4-4150-8271-020BC6FC9010}"/>
               </a:ext>
             </a:extLst>
           </p:cNvPr>
@@ -1400,7 +1400,7 @@
           <p:cNvPr id="3" name="">
             <a:extLst xmlns:a="http://schemas.openxmlformats.org/drawingml/2006/main">
               <a:ext uri="{FF2B5EF4-FFF2-40B4-BE49-F238E27FC236}">
-                <a16:creationId xmlns:a16="http://schemas.microsoft.com/office/drawing/2014/main" id="{D794C5B6-B736-4504-9C25-8E115F446219}"/>
+                <a16:creationId xmlns:a16="http://schemas.microsoft.com/office/drawing/2014/main" id="{932CAD91-F822-4EB9-BC9C-A3F4E3B6A8F6}"/>
               </a:ext>
             </a:extLst>
           </p:cNvPr>
@@ -1457,7 +1457,7 @@
           <p:cNvPr id="4" name="">
             <a:extLst xmlns:a="http://schemas.openxmlformats.org/drawingml/2006/main">
               <a:ext uri="{FF2B5EF4-FFF2-40B4-BE49-F238E27FC236}">
-                <a16:creationId xmlns:a16="http://schemas.microsoft.com/office/drawing/2014/main" id="{274C8F75-5319-415A-8370-8FF1E77B4DBD}"/>
+                <a16:creationId xmlns:a16="http://schemas.microsoft.com/office/drawing/2014/main" id="{BFDD9D01-D525-4AFA-98D7-60A2C8BC4AA6}"/>
               </a:ext>
             </a:extLst>
           </p:cNvPr>
@@ -1560,7 +1560,7 @@
           <p:cNvPr id="5" name="">
             <a:extLst xmlns:a="http://schemas.openxmlformats.org/drawingml/2006/main">
               <a:ext uri="{FF2B5EF4-FFF2-40B4-BE49-F238E27FC236}">
-                <a16:creationId xmlns:a16="http://schemas.microsoft.com/office/drawing/2014/main" id="{B1E7442A-D526-488C-992B-E5C8EB027099}"/>
+                <a16:creationId xmlns:a16="http://schemas.microsoft.com/office/drawing/2014/main" id="{B1FAA834-69FD-44A7-828B-0FAEF01A018C}"/>
               </a:ext>
             </a:extLst>
           </p:cNvPr>
@@ -1617,7 +1617,7 @@
           <p:cNvPr id="6" name="">
             <a:extLst xmlns:a="http://schemas.openxmlformats.org/drawingml/2006/main">
               <a:ext uri="{FF2B5EF4-FFF2-40B4-BE49-F238E27FC236}">
-                <a16:creationId xmlns:a16="http://schemas.microsoft.com/office/drawing/2014/main" id="{DFD24948-EE81-4DB1-82F0-BD05D5111FC2}"/>
+                <a16:creationId xmlns:a16="http://schemas.microsoft.com/office/drawing/2014/main" id="{3CE79009-9A13-417A-A62F-053261CBDCE9}"/>
               </a:ext>
             </a:extLst>
           </p:cNvPr>
@@ -1672,7 +1672,7 @@
     </p:spTree>
     <p:extLst>
       <p:ext uri="{BB962C8B-B14F-4D97-AF65-F5344CB8AC3E}">
-        <p14:creationId xmlns:p14="http://schemas.microsoft.com/office/powerpoint/2010/main" val="623763796"/>
+        <p14:creationId xmlns:p14="http://schemas.microsoft.com/office/powerpoint/2010/main" val="2046820633"/>
       </p:ext>
     </p:extLst>
   </p:cSld>
@@ -1703,7 +1703,7 @@
           <p:cNvPr id="13" name="">
             <a:extLst xmlns:a="http://schemas.openxmlformats.org/drawingml/2006/main">
               <a:ext uri="{FF2B5EF4-FFF2-40B4-BE49-F238E27FC236}">
-                <a16:creationId xmlns:a16="http://schemas.microsoft.com/office/drawing/2014/main" id="{8FAC460E-5CC8-49B4-B02F-6F3812A27DB9}"/>
+                <a16:creationId xmlns:a16="http://schemas.microsoft.com/office/drawing/2014/main" id="{1BC3456E-9600-43DF-9747-22C644931DAE}"/>
               </a:ext>
             </a:extLst>
           </p:cNvPr>
@@ -1760,7 +1760,7 @@
           <p:cNvPr id="2" name="">
             <a:extLst xmlns:a="http://schemas.openxmlformats.org/drawingml/2006/main">
               <a:ext uri="{FF2B5EF4-FFF2-40B4-BE49-F238E27FC236}">
-                <a16:creationId xmlns:a16="http://schemas.microsoft.com/office/drawing/2014/main" id="{39AA55B1-FCF0-4B36-BB43-B9368FB89C1C}"/>
+                <a16:creationId xmlns:a16="http://schemas.microsoft.com/office/drawing/2014/main" id="{E3ADF1DB-E81C-479C-BC53-0A3941BC51A2}"/>
               </a:ext>
             </a:extLst>
           </p:cNvPr>
@@ -1817,7 +1817,7 @@
           <p:cNvPr id="3" name="">
             <a:extLst xmlns:a="http://schemas.openxmlformats.org/drawingml/2006/main">
               <a:ext uri="{FF2B5EF4-FFF2-40B4-BE49-F238E27FC236}">
-                <a16:creationId xmlns:a16="http://schemas.microsoft.com/office/drawing/2014/main" id="{B702168F-DD7E-4FEB-9063-17030DD8E71E}"/>
+                <a16:creationId xmlns:a16="http://schemas.microsoft.com/office/drawing/2014/main" id="{925123DC-D7A9-4E8A-B3B6-13FCDB3CC3A0}"/>
               </a:ext>
             </a:extLst>
           </p:cNvPr>
@@ -1874,7 +1874,7 @@
           <p:cNvPr id="4" name="">
             <a:extLst xmlns:a="http://schemas.openxmlformats.org/drawingml/2006/main">
               <a:ext uri="{FF2B5EF4-FFF2-40B4-BE49-F238E27FC236}">
-                <a16:creationId xmlns:a16="http://schemas.microsoft.com/office/drawing/2014/main" id="{043EADF5-EBBC-4A14-B6CA-B4447BFBD47C}"/>
+                <a16:creationId xmlns:a16="http://schemas.microsoft.com/office/drawing/2014/main" id="{BD5CA67F-E83A-4EE6-A180-1CE4A5ACEBF6}"/>
               </a:ext>
             </a:extLst>
           </p:cNvPr>
@@ -1958,7 +1958,7 @@
           <p:cNvPr id="5" name="">
             <a:extLst xmlns:a="http://schemas.openxmlformats.org/drawingml/2006/main">
               <a:ext uri="{FF2B5EF4-FFF2-40B4-BE49-F238E27FC236}">
-                <a16:creationId xmlns:a16="http://schemas.microsoft.com/office/drawing/2014/main" id="{D2F9911D-E602-4614-9FFA-24398FE40D73}"/>
+                <a16:creationId xmlns:a16="http://schemas.microsoft.com/office/drawing/2014/main" id="{2484C547-B563-49FA-A530-5A5ADA4121AF}"/>
               </a:ext>
             </a:extLst>
           </p:cNvPr>
@@ -2042,7 +2042,7 @@
           <p:cNvPr id="6" name="">
             <a:extLst xmlns:a="http://schemas.openxmlformats.org/drawingml/2006/main">
               <a:ext uri="{FF2B5EF4-FFF2-40B4-BE49-F238E27FC236}">
-                <a16:creationId xmlns:a16="http://schemas.microsoft.com/office/drawing/2014/main" id="{DE533EAA-08D1-4EC4-8F70-6B4F3EFD7014}"/>
+                <a16:creationId xmlns:a16="http://schemas.microsoft.com/office/drawing/2014/main" id="{FF4D6FA5-3F87-423A-BA21-0F8626FF4ECD}"/>
               </a:ext>
             </a:extLst>
           </p:cNvPr>
@@ -2126,7 +2126,7 @@
           <p:cNvPr id="7" name="">
             <a:extLst xmlns:a="http://schemas.openxmlformats.org/drawingml/2006/main">
               <a:ext uri="{FF2B5EF4-FFF2-40B4-BE49-F238E27FC236}">
-                <a16:creationId xmlns:a16="http://schemas.microsoft.com/office/drawing/2014/main" id="{BDEC91BF-C754-46D4-A789-1783FC4570A7}"/>
+                <a16:creationId xmlns:a16="http://schemas.microsoft.com/office/drawing/2014/main" id="{4A4DBCE8-B68F-4CD3-A288-45C1F428B479}"/>
               </a:ext>
             </a:extLst>
           </p:cNvPr>
@@ -2288,7 +2288,7 @@
           <p:cNvPr id="11" name="">
             <a:extLst xmlns:a="http://schemas.openxmlformats.org/drawingml/2006/main">
               <a:ext uri="{FF2B5EF4-FFF2-40B4-BE49-F238E27FC236}">
-                <a16:creationId xmlns:a16="http://schemas.microsoft.com/office/drawing/2014/main" id="{B43AF6EF-8D3E-44AE-98BC-F3C838670F84}"/>
+                <a16:creationId xmlns:a16="http://schemas.microsoft.com/office/drawing/2014/main" id="{11032270-20F9-4A08-8A08-1F3BF89C84DA}"/>
               </a:ext>
             </a:extLst>
           </p:cNvPr>
@@ -2345,7 +2345,7 @@
           <p:cNvPr id="12" name="">
             <a:extLst xmlns:a="http://schemas.openxmlformats.org/drawingml/2006/main">
               <a:ext uri="{FF2B5EF4-FFF2-40B4-BE49-F238E27FC236}">
-                <a16:creationId xmlns:a16="http://schemas.microsoft.com/office/drawing/2014/main" id="{C51D02B7-D165-400B-9EEF-2E3AC6C88794}"/>
+                <a16:creationId xmlns:a16="http://schemas.microsoft.com/office/drawing/2014/main" id="{3BB1C224-125F-4AB3-9086-6793EC6CAD9F}"/>
               </a:ext>
             </a:extLst>
           </p:cNvPr>
@@ -2400,7 +2400,7 @@
     </p:spTree>
     <p:extLst>
       <p:ext uri="{BB962C8B-B14F-4D97-AF65-F5344CB8AC3E}">
-        <p14:creationId xmlns:p14="http://schemas.microsoft.com/office/powerpoint/2010/main" val="389264615"/>
+        <p14:creationId xmlns:p14="http://schemas.microsoft.com/office/powerpoint/2010/main" val="1639094115"/>
       </p:ext>
     </p:extLst>
   </p:cSld>
@@ -2431,7 +2431,7 @@
           <p:cNvPr id="8" name="">
             <a:extLst xmlns:a="http://schemas.openxmlformats.org/drawingml/2006/main">
               <a:ext uri="{FF2B5EF4-FFF2-40B4-BE49-F238E27FC236}">
-                <a16:creationId xmlns:a16="http://schemas.microsoft.com/office/drawing/2014/main" id="{3BC7E928-D3AB-409C-ABDA-53693B9E7DED}"/>
+                <a16:creationId xmlns:a16="http://schemas.microsoft.com/office/drawing/2014/main" id="{310F5B05-9A93-4233-8F6A-AC64465E656E}"/>
               </a:ext>
             </a:extLst>
           </p:cNvPr>
@@ -2488,7 +2488,7 @@
           <p:cNvPr id="2" name="">
             <a:extLst xmlns:a="http://schemas.openxmlformats.org/drawingml/2006/main">
               <a:ext uri="{FF2B5EF4-FFF2-40B4-BE49-F238E27FC236}">
-                <a16:creationId xmlns:a16="http://schemas.microsoft.com/office/drawing/2014/main" id="{E16DC21D-B606-45EF-9F92-D315093E87D4}"/>
+                <a16:creationId xmlns:a16="http://schemas.microsoft.com/office/drawing/2014/main" id="{A84CDB18-DFB0-4183-B9F6-3B759D719BA8}"/>
               </a:ext>
             </a:extLst>
           </p:cNvPr>
@@ -2568,7 +2568,7 @@
           <p:cNvPr id="3" name="">
             <a:extLst xmlns:a="http://schemas.openxmlformats.org/drawingml/2006/main">
               <a:ext uri="{FF2B5EF4-FFF2-40B4-BE49-F238E27FC236}">
-                <a16:creationId xmlns:a16="http://schemas.microsoft.com/office/drawing/2014/main" id="{7DA7D27F-1820-4949-AA4C-0BCBA9F6E99A}"/>
+                <a16:creationId xmlns:a16="http://schemas.microsoft.com/office/drawing/2014/main" id="{4073BD37-F263-40E0-8B76-49E4C20167E0}"/>
               </a:ext>
             </a:extLst>
           </p:cNvPr>
@@ -2625,7 +2625,7 @@
           <p:cNvPr id="4" name="">
             <a:extLst xmlns:a="http://schemas.openxmlformats.org/drawingml/2006/main">
               <a:ext uri="{FF2B5EF4-FFF2-40B4-BE49-F238E27FC236}">
-                <a16:creationId xmlns:a16="http://schemas.microsoft.com/office/drawing/2014/main" id="{74862F9D-55B3-41FF-A797-FDCC14C2BE14}"/>
+                <a16:creationId xmlns:a16="http://schemas.microsoft.com/office/drawing/2014/main" id="{DD989AC5-6AA3-4E10-ADCB-12790B1DD2A3}"/>
               </a:ext>
             </a:extLst>
           </p:cNvPr>
@@ -2672,7 +2672,7 @@
                 <a:ea typeface="Arial"/>
                 <a:cs typeface="Arial"/>
               </a:rPr>
-              <a:t>40 unit and integration tests</a:t>
+              <a:t>44 unit and integration tests</a:t>
             </a:r>
           </a:p>
           <a:p xmlns:a="http://schemas.openxmlformats.org/drawingml/2006/main">
@@ -2695,7 +2695,7 @@
                 <a:ea typeface="Arial"/>
                 <a:cs typeface="Arial"/>
               </a:rPr>
-              <a:t>10 Chromium browser checks</a:t>
+              <a:t>13 Chromium browser checks</a:t>
             </a:r>
           </a:p>
         </p:txBody>
@@ -2705,7 +2705,7 @@
           <p:cNvPr id="5" name="">
             <a:extLst xmlns:a="http://schemas.openxmlformats.org/drawingml/2006/main">
               <a:ext uri="{FF2B5EF4-FFF2-40B4-BE49-F238E27FC236}">
-                <a16:creationId xmlns:a16="http://schemas.microsoft.com/office/drawing/2014/main" id="{4E8E6D7A-728B-469C-8A4D-85C16512D584}"/>
+                <a16:creationId xmlns:a16="http://schemas.microsoft.com/office/drawing/2014/main" id="{96124F51-7ED9-429D-9B25-F061714F7A19}"/>
               </a:ext>
             </a:extLst>
           </p:cNvPr>
@@ -2762,7 +2762,7 @@
           <p:cNvPr id="6" name="">
             <a:extLst xmlns:a="http://schemas.openxmlformats.org/drawingml/2006/main">
               <a:ext uri="{FF2B5EF4-FFF2-40B4-BE49-F238E27FC236}">
-                <a16:creationId xmlns:a16="http://schemas.microsoft.com/office/drawing/2014/main" id="{B99E63A5-B97C-410C-847A-BB049269749E}"/>
+                <a16:creationId xmlns:a16="http://schemas.microsoft.com/office/drawing/2014/main" id="{31A04766-5723-4605-8A01-1B1D959C781E}"/>
               </a:ext>
             </a:extLst>
           </p:cNvPr>
@@ -2819,7 +2819,7 @@
           <p:cNvPr id="7" name="">
             <a:extLst xmlns:a="http://schemas.openxmlformats.org/drawingml/2006/main">
               <a:ext uri="{FF2B5EF4-FFF2-40B4-BE49-F238E27FC236}">
-                <a16:creationId xmlns:a16="http://schemas.microsoft.com/office/drawing/2014/main" id="{ADD764B8-C582-4F14-A9A3-8B722F30F8CA}"/>
+                <a16:creationId xmlns:a16="http://schemas.microsoft.com/office/drawing/2014/main" id="{B6C6BF17-BC37-4600-98A2-234D817FCBA1}"/>
               </a:ext>
             </a:extLst>
           </p:cNvPr>
@@ -2874,7 +2874,7 @@
     </p:spTree>
     <p:extLst>
       <p:ext uri="{BB962C8B-B14F-4D97-AF65-F5344CB8AC3E}">
-        <p14:creationId xmlns:p14="http://schemas.microsoft.com/office/powerpoint/2010/main" val="322683714"/>
+        <p14:creationId xmlns:p14="http://schemas.microsoft.com/office/powerpoint/2010/main" val="581716849"/>
       </p:ext>
     </p:extLst>
   </p:cSld>

</xml_diff>